<commit_message>
Protecting the categories relations
</commit_message>
<xml_diff>
--- a/.lessons/56 Category, Subcategory and Child Category Setup/19 Protecting the categories relations/1.pptx
+++ b/.lessons/56 Category, Subcategory and Child Category Setup/19 Protecting the categories relations/1.pptx
@@ -8,6 +8,13 @@
     <p:sldId id="413" r:id="rId2"/>
     <p:sldId id="414" r:id="rId3"/>
     <p:sldId id="400" r:id="rId4"/>
+    <p:sldId id="415" r:id="rId5"/>
+    <p:sldId id="416" r:id="rId6"/>
+    <p:sldId id="417" r:id="rId7"/>
+    <p:sldId id="419" r:id="rId8"/>
+    <p:sldId id="420" r:id="rId9"/>
+    <p:sldId id="421" r:id="rId10"/>
+    <p:sldId id="418" r:id="rId11"/>
   </p:sldIdLst>
   <p:sldSz cx="12192000" cy="6858000"/>
   <p:notesSz cx="6858000" cy="9144000"/>
@@ -261,7 +268,7 @@
           <a:p>
             <a:fld id="{3E102D2E-813C-461C-9963-687A650C48C0}" type="datetimeFigureOut">
               <a:rPr lang="en-US" smtClean="0"/>
-              <a:t>6/26/2025</a:t>
+              <a:t>8/28/2025</a:t>
             </a:fld>
             <a:endParaRPr lang="en-US"/>
           </a:p>
@@ -459,7 +466,7 @@
           <a:p>
             <a:fld id="{3E102D2E-813C-461C-9963-687A650C48C0}" type="datetimeFigureOut">
               <a:rPr lang="en-US" smtClean="0"/>
-              <a:t>6/26/2025</a:t>
+              <a:t>8/28/2025</a:t>
             </a:fld>
             <a:endParaRPr lang="en-US"/>
           </a:p>
@@ -667,7 +674,7 @@
           <a:p>
             <a:fld id="{3E102D2E-813C-461C-9963-687A650C48C0}" type="datetimeFigureOut">
               <a:rPr lang="en-US" smtClean="0"/>
-              <a:t>6/26/2025</a:t>
+              <a:t>8/28/2025</a:t>
             </a:fld>
             <a:endParaRPr lang="en-US"/>
           </a:p>
@@ -865,7 +872,7 @@
           <a:p>
             <a:fld id="{3E102D2E-813C-461C-9963-687A650C48C0}" type="datetimeFigureOut">
               <a:rPr lang="en-US" smtClean="0"/>
-              <a:t>6/26/2025</a:t>
+              <a:t>8/28/2025</a:t>
             </a:fld>
             <a:endParaRPr lang="en-US"/>
           </a:p>
@@ -1140,7 +1147,7 @@
           <a:p>
             <a:fld id="{3E102D2E-813C-461C-9963-687A650C48C0}" type="datetimeFigureOut">
               <a:rPr lang="en-US" smtClean="0"/>
-              <a:t>6/26/2025</a:t>
+              <a:t>8/28/2025</a:t>
             </a:fld>
             <a:endParaRPr lang="en-US"/>
           </a:p>
@@ -1405,7 +1412,7 @@
           <a:p>
             <a:fld id="{3E102D2E-813C-461C-9963-687A650C48C0}" type="datetimeFigureOut">
               <a:rPr lang="en-US" smtClean="0"/>
-              <a:t>6/26/2025</a:t>
+              <a:t>8/28/2025</a:t>
             </a:fld>
             <a:endParaRPr lang="en-US"/>
           </a:p>
@@ -1817,7 +1824,7 @@
           <a:p>
             <a:fld id="{3E102D2E-813C-461C-9963-687A650C48C0}" type="datetimeFigureOut">
               <a:rPr lang="en-US" smtClean="0"/>
-              <a:t>6/26/2025</a:t>
+              <a:t>8/28/2025</a:t>
             </a:fld>
             <a:endParaRPr lang="en-US"/>
           </a:p>
@@ -1958,7 +1965,7 @@
           <a:p>
             <a:fld id="{3E102D2E-813C-461C-9963-687A650C48C0}" type="datetimeFigureOut">
               <a:rPr lang="en-US" smtClean="0"/>
-              <a:t>6/26/2025</a:t>
+              <a:t>8/28/2025</a:t>
             </a:fld>
             <a:endParaRPr lang="en-US"/>
           </a:p>
@@ -2071,7 +2078,7 @@
           <a:p>
             <a:fld id="{3E102D2E-813C-461C-9963-687A650C48C0}" type="datetimeFigureOut">
               <a:rPr lang="en-US" smtClean="0"/>
-              <a:t>6/26/2025</a:t>
+              <a:t>8/28/2025</a:t>
             </a:fld>
             <a:endParaRPr lang="en-US"/>
           </a:p>
@@ -2382,7 +2389,7 @@
           <a:p>
             <a:fld id="{3E102D2E-813C-461C-9963-687A650C48C0}" type="datetimeFigureOut">
               <a:rPr lang="en-US" smtClean="0"/>
-              <a:t>6/26/2025</a:t>
+              <a:t>8/28/2025</a:t>
             </a:fld>
             <a:endParaRPr lang="en-US"/>
           </a:p>
@@ -2670,7 +2677,7 @@
           <a:p>
             <a:fld id="{3E102D2E-813C-461C-9963-687A650C48C0}" type="datetimeFigureOut">
               <a:rPr lang="en-US" smtClean="0"/>
-              <a:t>6/26/2025</a:t>
+              <a:t>8/28/2025</a:t>
             </a:fld>
             <a:endParaRPr lang="en-US"/>
           </a:p>
@@ -2911,7 +2918,7 @@
           <a:p>
             <a:fld id="{3E102D2E-813C-461C-9963-687A650C48C0}" type="datetimeFigureOut">
               <a:rPr lang="en-US" smtClean="0"/>
-              <a:t>6/26/2025</a:t>
+              <a:t>8/28/2025</a:t>
             </a:fld>
             <a:endParaRPr lang="en-US"/>
           </a:p>
@@ -3334,12 +3341,208 @@
           <a:chExt cx="0" cy="0"/>
         </a:xfrm>
       </p:grpSpPr>
+      <p:pic>
+        <p:nvPicPr>
+          <p:cNvPr id="4" name="Picture 3">
+            <a:extLst>
+              <a:ext uri="{FF2B5EF4-FFF2-40B4-BE49-F238E27FC236}">
+                <a16:creationId xmlns:a16="http://schemas.microsoft.com/office/drawing/2014/main" id="{22ED16D4-2566-0D60-EDC6-297674835459}"/>
+              </a:ext>
+            </a:extLst>
+          </p:cNvPr>
+          <p:cNvPicPr>
+            <a:picLocks noChangeAspect="1"/>
+          </p:cNvPicPr>
+          <p:nvPr/>
+        </p:nvPicPr>
+        <p:blipFill>
+          <a:blip r:embed="rId2"/>
+          <a:srcRect b="5692"/>
+          <a:stretch>
+            <a:fillRect/>
+          </a:stretch>
+        </p:blipFill>
+        <p:spPr>
+          <a:xfrm>
+            <a:off x="-1" y="0"/>
+            <a:ext cx="12192000" cy="3343564"/>
+          </a:xfrm>
+          <a:prstGeom prst="rect">
+            <a:avLst/>
+          </a:prstGeom>
+          <a:ln w="38100" cap="sq">
+            <a:solidFill>
+              <a:srgbClr val="000000"/>
+            </a:solidFill>
+            <a:prstDash val="solid"/>
+            <a:miter lim="800000"/>
+          </a:ln>
+          <a:effectLst>
+            <a:outerShdw blurRad="50800" dist="38100" dir="2700000" algn="tl" rotWithShape="0">
+              <a:srgbClr val="000000">
+                <a:alpha val="43000"/>
+              </a:srgbClr>
+            </a:outerShdw>
+          </a:effectLst>
+        </p:spPr>
+      </p:pic>
+      <p:pic>
+        <p:nvPicPr>
+          <p:cNvPr id="6" name="Picture 5">
+            <a:extLst>
+              <a:ext uri="{FF2B5EF4-FFF2-40B4-BE49-F238E27FC236}">
+                <a16:creationId xmlns:a16="http://schemas.microsoft.com/office/drawing/2014/main" id="{64CB9455-7393-0CBA-8638-76C9B94F5BA1}"/>
+              </a:ext>
+            </a:extLst>
+          </p:cNvPr>
+          <p:cNvPicPr>
+            <a:picLocks noChangeAspect="1"/>
+          </p:cNvPicPr>
+          <p:nvPr/>
+        </p:nvPicPr>
+        <p:blipFill>
+          <a:blip r:embed="rId3"/>
+          <a:stretch>
+            <a:fillRect/>
+          </a:stretch>
+        </p:blipFill>
+        <p:spPr>
+          <a:xfrm>
+            <a:off x="-1" y="4012987"/>
+            <a:ext cx="12192000" cy="2845013"/>
+          </a:xfrm>
+          <a:prstGeom prst="rect">
+            <a:avLst/>
+          </a:prstGeom>
+          <a:ln w="38100" cap="sq">
+            <a:solidFill>
+              <a:srgbClr val="000000"/>
+            </a:solidFill>
+            <a:prstDash val="solid"/>
+            <a:miter lim="800000"/>
+          </a:ln>
+          <a:effectLst>
+            <a:outerShdw blurRad="50800" dist="38100" dir="2700000" algn="tl" rotWithShape="0">
+              <a:srgbClr val="000000">
+                <a:alpha val="43000"/>
+              </a:srgbClr>
+            </a:outerShdw>
+          </a:effectLst>
+        </p:spPr>
+      </p:pic>
+      <p:sp>
+        <p:nvSpPr>
+          <p:cNvPr id="7" name="TextBox 6">
+            <a:extLst>
+              <a:ext uri="{FF2B5EF4-FFF2-40B4-BE49-F238E27FC236}">
+                <a16:creationId xmlns:a16="http://schemas.microsoft.com/office/drawing/2014/main" id="{A727ABBC-76D0-B81B-760F-26FC272AF479}"/>
+              </a:ext>
+            </a:extLst>
+          </p:cNvPr>
+          <p:cNvSpPr txBox="1"/>
+          <p:nvPr/>
+        </p:nvSpPr>
+        <p:spPr>
+          <a:xfrm>
+            <a:off x="0" y="3514437"/>
+            <a:ext cx="12192000" cy="355354"/>
+          </a:xfrm>
+          <a:prstGeom prst="rect">
+            <a:avLst/>
+          </a:prstGeom>
+          <a:noFill/>
+        </p:spPr>
+        <p:txBody>
+          <a:bodyPr wrap="square">
+            <a:spAutoFit/>
+          </a:bodyPr>
+          <a:lstStyle/>
+          <a:p>
+            <a:pPr>
+              <a:lnSpc>
+                <a:spcPct val="150000"/>
+              </a:lnSpc>
+              <a:buNone/>
+            </a:pPr>
+            <a:r>
+              <a:rPr lang="az-Latn-AZ" altLang="en-US" sz="1300" b="1">
+                <a:latin typeface="Arial" panose="020B0604020202020204" pitchFamily="34" charset="0"/>
+              </a:rPr>
+              <a:t>Category</a:t>
+            </a:r>
+            <a:r>
+              <a:rPr lang="az-Latn-AZ" altLang="en-US" sz="1300">
+                <a:latin typeface="Arial" panose="020B0604020202020204" pitchFamily="34" charset="0"/>
+              </a:rPr>
+              <a:t> -ləri sildik, </a:t>
+            </a:r>
+            <a:r>
+              <a:rPr lang="az-Latn-AZ" altLang="en-US" sz="1300" b="1">
+                <a:latin typeface="Arial" panose="020B0604020202020204" pitchFamily="34" charset="0"/>
+              </a:rPr>
+              <a:t>Sub Category </a:t>
+            </a:r>
+            <a:r>
+              <a:rPr lang="az-Latn-AZ" altLang="en-US" sz="1300">
+                <a:latin typeface="Arial" panose="020B0604020202020204" pitchFamily="34" charset="0"/>
+              </a:rPr>
+              <a:t>-lər açılmır.</a:t>
+            </a:r>
+            <a:endParaRPr kumimoji="0" lang="en-US" altLang="en-US" sz="1300" b="0" i="0" u="none" strike="noStrike" cap="none" normalizeH="0" baseline="0">
+              <a:ln>
+                <a:noFill/>
+              </a:ln>
+              <a:solidFill>
+                <a:schemeClr val="tx1"/>
+              </a:solidFill>
+              <a:effectLst/>
+              <a:latin typeface="Arial" panose="020B0604020202020204" pitchFamily="34" charset="0"/>
+            </a:endParaRPr>
+          </a:p>
+        </p:txBody>
+      </p:sp>
+    </p:spTree>
+    <p:extLst>
+      <p:ext uri="{BB962C8B-B14F-4D97-AF65-F5344CB8AC3E}">
+        <p14:creationId xmlns:p14="http://schemas.microsoft.com/office/powerpoint/2010/main" val="3863838039"/>
+      </p:ext>
+    </p:extLst>
+  </p:cSld>
+  <p:clrMapOvr>
+    <a:masterClrMapping/>
+  </p:clrMapOvr>
+</p:sld>
+</file>
+
+<file path=ppt/slides/slide10.xml><?xml version="1.0" encoding="utf-8"?>
+<p:sld xmlns:a="http://schemas.openxmlformats.org/drawingml/2006/main" xmlns:r="http://schemas.openxmlformats.org/officeDocument/2006/relationships" xmlns:p="http://schemas.openxmlformats.org/presentationml/2006/main">
+  <p:cSld>
+    <p:spTree>
+      <p:nvGrpSpPr>
+        <p:cNvPr id="1" name="">
+          <a:extLst>
+            <a:ext uri="{FF2B5EF4-FFF2-40B4-BE49-F238E27FC236}">
+              <a16:creationId xmlns:a16="http://schemas.microsoft.com/office/drawing/2014/main" id="{31FE183A-48ED-98CD-146E-3E858ADD8C2B}"/>
+            </a:ext>
+          </a:extLst>
+        </p:cNvPr>
+        <p:cNvGrpSpPr/>
+        <p:nvPr/>
+      </p:nvGrpSpPr>
+      <p:grpSpPr>
+        <a:xfrm>
+          <a:off x="0" y="0"/>
+          <a:ext cx="0" cy="0"/>
+          <a:chOff x="0" y="0"/>
+          <a:chExt cx="0" cy="0"/>
+        </a:xfrm>
+      </p:grpSpPr>
       <p:sp>
         <p:nvSpPr>
           <p:cNvPr id="3" name="TextBox 2">
             <a:extLst>
               <a:ext uri="{FF2B5EF4-FFF2-40B4-BE49-F238E27FC236}">
-                <a16:creationId xmlns:a16="http://schemas.microsoft.com/office/drawing/2014/main" id="{A727ABBC-76D0-B81B-760F-26FC272AF479}"/>
+                <a16:creationId xmlns:a16="http://schemas.microsoft.com/office/drawing/2014/main" id="{2BFE28C1-34D2-3076-1349-C3B2F64E7773}"/>
               </a:ext>
             </a:extLst>
           </p:cNvPr>
@@ -3387,7 +3590,7 @@
     </p:spTree>
     <p:extLst>
       <p:ext uri="{BB962C8B-B14F-4D97-AF65-F5344CB8AC3E}">
-        <p14:creationId xmlns:p14="http://schemas.microsoft.com/office/powerpoint/2010/main" val="3863838039"/>
+        <p14:creationId xmlns:p14="http://schemas.microsoft.com/office/powerpoint/2010/main" val="3840922839"/>
       </p:ext>
     </p:extLst>
   </p:cSld>
@@ -3435,7 +3638,7 @@
         <p:spPr>
           <a:xfrm>
             <a:off x="217714" y="255046"/>
-            <a:ext cx="11756571" cy="355354"/>
+            <a:ext cx="11756571" cy="655436"/>
           </a:xfrm>
           <a:prstGeom prst="rect">
             <a:avLst/>
@@ -3455,21 +3658,149 @@
               <a:buNone/>
             </a:pPr>
             <a:r>
-              <a:rPr kumimoji="0" lang="en-US" altLang="en-US" sz="1300" b="0" i="0" u="none" strike="noStrike" cap="none" normalizeH="0" baseline="0">
-                <a:ln>
-                  <a:noFill/>
-                </a:ln>
-                <a:solidFill>
-                  <a:schemeClr val="tx1"/>
-                </a:solidFill>
-                <a:effectLst/>
-                <a:latin typeface="Arial" panose="020B0604020202020204" pitchFamily="34" charset="0"/>
-              </a:rPr>
-              <a:t>.</a:t>
-            </a:r>
-          </a:p>
-        </p:txBody>
-      </p:sp>
+              <a:rPr lang="az-Latn-AZ" altLang="en-US" sz="1300">
+                <a:latin typeface="Arial" panose="020B0604020202020204" pitchFamily="34" charset="0"/>
+              </a:rPr>
+              <a:t>Səbəb isə, </a:t>
+            </a:r>
+            <a:r>
+              <a:rPr lang="az-Latn-AZ" altLang="en-US" sz="1300" b="1">
+                <a:latin typeface="Arial" panose="020B0604020202020204" pitchFamily="34" charset="0"/>
+              </a:rPr>
+              <a:t>Sub Category </a:t>
+            </a:r>
+            <a:r>
+              <a:rPr lang="az-Latn-AZ" altLang="en-US" sz="1300">
+                <a:latin typeface="Arial" panose="020B0604020202020204" pitchFamily="34" charset="0"/>
+              </a:rPr>
+              <a:t>-inin məlumatlarının </a:t>
+            </a:r>
+            <a:r>
+              <a:rPr lang="az-Latn-AZ" altLang="en-US" sz="1300" b="1">
+                <a:latin typeface="Arial" panose="020B0604020202020204" pitchFamily="34" charset="0"/>
+              </a:rPr>
+              <a:t>DB</a:t>
+            </a:r>
+            <a:r>
+              <a:rPr lang="az-Latn-AZ" altLang="en-US" sz="1300">
+                <a:latin typeface="Arial" panose="020B0604020202020204" pitchFamily="34" charset="0"/>
+              </a:rPr>
+              <a:t> -də hələdə mövcud olması ilə bağlıdır. </a:t>
+            </a:r>
+            <a:r>
+              <a:rPr lang="az-Latn-AZ" altLang="en-US" sz="1300" b="1">
+                <a:latin typeface="Arial" panose="020B0604020202020204" pitchFamily="34" charset="0"/>
+              </a:rPr>
+              <a:t>Manual</a:t>
+            </a:r>
+            <a:r>
+              <a:rPr lang="az-Latn-AZ" altLang="en-US" sz="1300">
+                <a:latin typeface="Arial" panose="020B0604020202020204" pitchFamily="34" charset="0"/>
+              </a:rPr>
+              <a:t> olaraq bu məlumatları silsək onda, şablonda olan xətanı artıq görməyəcəyik. Mən sildim.</a:t>
+            </a:r>
+            <a:endParaRPr kumimoji="0" lang="en-US" altLang="en-US" sz="1300" b="0" i="0" u="none" strike="noStrike" cap="none" normalizeH="0" baseline="0">
+              <a:ln>
+                <a:noFill/>
+              </a:ln>
+              <a:solidFill>
+                <a:schemeClr val="tx1"/>
+              </a:solidFill>
+              <a:effectLst/>
+              <a:latin typeface="Arial" panose="020B0604020202020204" pitchFamily="34" charset="0"/>
+            </a:endParaRPr>
+          </a:p>
+        </p:txBody>
+      </p:sp>
+      <p:pic>
+        <p:nvPicPr>
+          <p:cNvPr id="4" name="Picture 3">
+            <a:extLst>
+              <a:ext uri="{FF2B5EF4-FFF2-40B4-BE49-F238E27FC236}">
+                <a16:creationId xmlns:a16="http://schemas.microsoft.com/office/drawing/2014/main" id="{AA585D99-AD52-8CA6-E320-0519F0CEED40}"/>
+              </a:ext>
+            </a:extLst>
+          </p:cNvPr>
+          <p:cNvPicPr>
+            <a:picLocks noChangeAspect="1"/>
+          </p:cNvPicPr>
+          <p:nvPr/>
+        </p:nvPicPr>
+        <p:blipFill>
+          <a:blip r:embed="rId2"/>
+          <a:srcRect b="44236"/>
+          <a:stretch>
+            <a:fillRect/>
+          </a:stretch>
+        </p:blipFill>
+        <p:spPr>
+          <a:xfrm>
+            <a:off x="0" y="1280162"/>
+            <a:ext cx="10974332" cy="1854000"/>
+          </a:xfrm>
+          <a:prstGeom prst="rect">
+            <a:avLst/>
+          </a:prstGeom>
+          <a:ln w="38100" cap="sq">
+            <a:solidFill>
+              <a:srgbClr val="000000"/>
+            </a:solidFill>
+            <a:prstDash val="solid"/>
+            <a:miter lim="800000"/>
+          </a:ln>
+          <a:effectLst>
+            <a:outerShdw blurRad="50800" dist="38100" dir="2700000" algn="tl" rotWithShape="0">
+              <a:srgbClr val="000000">
+                <a:alpha val="43000"/>
+              </a:srgbClr>
+            </a:outerShdw>
+          </a:effectLst>
+        </p:spPr>
+      </p:pic>
+      <p:pic>
+        <p:nvPicPr>
+          <p:cNvPr id="6" name="Picture 5">
+            <a:extLst>
+              <a:ext uri="{FF2B5EF4-FFF2-40B4-BE49-F238E27FC236}">
+                <a16:creationId xmlns:a16="http://schemas.microsoft.com/office/drawing/2014/main" id="{76AD3007-6255-A76B-C616-DAEA9B203977}"/>
+              </a:ext>
+            </a:extLst>
+          </p:cNvPr>
+          <p:cNvPicPr>
+            <a:picLocks noChangeAspect="1"/>
+          </p:cNvPicPr>
+          <p:nvPr/>
+        </p:nvPicPr>
+        <p:blipFill>
+          <a:blip r:embed="rId3"/>
+          <a:stretch>
+            <a:fillRect/>
+          </a:stretch>
+        </p:blipFill>
+        <p:spPr>
+          <a:xfrm>
+            <a:off x="0" y="3723838"/>
+            <a:ext cx="10993384" cy="3134162"/>
+          </a:xfrm>
+          <a:prstGeom prst="rect">
+            <a:avLst/>
+          </a:prstGeom>
+          <a:ln w="38100" cap="sq">
+            <a:solidFill>
+              <a:srgbClr val="000000"/>
+            </a:solidFill>
+            <a:prstDash val="solid"/>
+            <a:miter lim="800000"/>
+          </a:ln>
+          <a:effectLst>
+            <a:outerShdw blurRad="50800" dist="38100" dir="2700000" algn="tl" rotWithShape="0">
+              <a:srgbClr val="000000">
+                <a:alpha val="43000"/>
+              </a:srgbClr>
+            </a:outerShdw>
+          </a:effectLst>
+        </p:spPr>
+      </p:pic>
     </p:spTree>
     <p:extLst>
       <p:ext uri="{BB962C8B-B14F-4D97-AF65-F5344CB8AC3E}">
@@ -3541,6 +3872,1058 @@
               <a:buNone/>
             </a:pPr>
             <a:r>
+              <a:rPr lang="az-Latn-AZ" altLang="en-US" sz="1300">
+                <a:latin typeface="Arial" panose="020B0604020202020204" pitchFamily="34" charset="0"/>
+              </a:rPr>
+              <a:t>Sildim.</a:t>
+            </a:r>
+            <a:endParaRPr kumimoji="0" lang="en-US" altLang="en-US" sz="1300" b="0" i="0" u="none" strike="noStrike" cap="none" normalizeH="0" baseline="0">
+              <a:ln>
+                <a:noFill/>
+              </a:ln>
+              <a:solidFill>
+                <a:schemeClr val="tx1"/>
+              </a:solidFill>
+              <a:effectLst/>
+              <a:latin typeface="Arial" panose="020B0604020202020204" pitchFamily="34" charset="0"/>
+            </a:endParaRPr>
+          </a:p>
+        </p:txBody>
+      </p:sp>
+      <p:pic>
+        <p:nvPicPr>
+          <p:cNvPr id="4" name="Picture 3">
+            <a:extLst>
+              <a:ext uri="{FF2B5EF4-FFF2-40B4-BE49-F238E27FC236}">
+                <a16:creationId xmlns:a16="http://schemas.microsoft.com/office/drawing/2014/main" id="{CDE7F50C-50CE-B700-75FE-8DFF3087438F}"/>
+              </a:ext>
+            </a:extLst>
+          </p:cNvPr>
+          <p:cNvPicPr>
+            <a:picLocks noChangeAspect="1"/>
+          </p:cNvPicPr>
+          <p:nvPr/>
+        </p:nvPicPr>
+        <p:blipFill>
+          <a:blip r:embed="rId2"/>
+          <a:stretch>
+            <a:fillRect/>
+          </a:stretch>
+        </p:blipFill>
+        <p:spPr>
+          <a:xfrm>
+            <a:off x="217714" y="1038308"/>
+            <a:ext cx="10964805" cy="2934109"/>
+          </a:xfrm>
+          <a:prstGeom prst="rect">
+            <a:avLst/>
+          </a:prstGeom>
+          <a:ln w="38100" cap="sq">
+            <a:solidFill>
+              <a:srgbClr val="000000"/>
+            </a:solidFill>
+            <a:prstDash val="solid"/>
+            <a:miter lim="800000"/>
+          </a:ln>
+          <a:effectLst>
+            <a:outerShdw blurRad="50800" dist="38100" dir="2700000" algn="tl" rotWithShape="0">
+              <a:srgbClr val="000000">
+                <a:alpha val="43000"/>
+              </a:srgbClr>
+            </a:outerShdw>
+          </a:effectLst>
+        </p:spPr>
+      </p:pic>
+    </p:spTree>
+    <p:extLst>
+      <p:ext uri="{BB962C8B-B14F-4D97-AF65-F5344CB8AC3E}">
+        <p14:creationId xmlns:p14="http://schemas.microsoft.com/office/powerpoint/2010/main" val="3095838342"/>
+      </p:ext>
+    </p:extLst>
+  </p:cSld>
+  <p:clrMapOvr>
+    <a:masterClrMapping/>
+  </p:clrMapOvr>
+</p:sld>
+</file>
+
+<file path=ppt/slides/slide4.xml><?xml version="1.0" encoding="utf-8"?>
+<p:sld xmlns:a="http://schemas.openxmlformats.org/drawingml/2006/main" xmlns:r="http://schemas.openxmlformats.org/officeDocument/2006/relationships" xmlns:p="http://schemas.openxmlformats.org/presentationml/2006/main">
+  <p:cSld>
+    <p:spTree>
+      <p:nvGrpSpPr>
+        <p:cNvPr id="1" name="">
+          <a:extLst>
+            <a:ext uri="{FF2B5EF4-FFF2-40B4-BE49-F238E27FC236}">
+              <a16:creationId xmlns:a16="http://schemas.microsoft.com/office/drawing/2014/main" id="{563EEC04-4DB1-0488-098A-DC17927AC510}"/>
+            </a:ext>
+          </a:extLst>
+        </p:cNvPr>
+        <p:cNvGrpSpPr/>
+        <p:nvPr/>
+      </p:nvGrpSpPr>
+      <p:grpSpPr>
+        <a:xfrm>
+          <a:off x="0" y="0"/>
+          <a:ext cx="0" cy="0"/>
+          <a:chOff x="0" y="0"/>
+          <a:chExt cx="0" cy="0"/>
+        </a:xfrm>
+      </p:grpSpPr>
+      <p:sp>
+        <p:nvSpPr>
+          <p:cNvPr id="3" name="TextBox 2">
+            <a:extLst>
+              <a:ext uri="{FF2B5EF4-FFF2-40B4-BE49-F238E27FC236}">
+                <a16:creationId xmlns:a16="http://schemas.microsoft.com/office/drawing/2014/main" id="{37DE4844-D8EC-8BC1-F420-A8F6AACAFF7E}"/>
+              </a:ext>
+            </a:extLst>
+          </p:cNvPr>
+          <p:cNvSpPr txBox="1"/>
+          <p:nvPr/>
+        </p:nvSpPr>
+        <p:spPr>
+          <a:xfrm>
+            <a:off x="217714" y="255046"/>
+            <a:ext cx="11756571" cy="355354"/>
+          </a:xfrm>
+          <a:prstGeom prst="rect">
+            <a:avLst/>
+          </a:prstGeom>
+          <a:noFill/>
+        </p:spPr>
+        <p:txBody>
+          <a:bodyPr wrap="square">
+            <a:spAutoFit/>
+          </a:bodyPr>
+          <a:lstStyle/>
+          <a:p>
+            <a:pPr>
+              <a:lnSpc>
+                <a:spcPct val="150000"/>
+              </a:lnSpc>
+              <a:buNone/>
+            </a:pPr>
+            <a:r>
+              <a:rPr lang="az-Latn-AZ" altLang="en-US" sz="1300">
+                <a:latin typeface="Arial" panose="020B0604020202020204" pitchFamily="34" charset="0"/>
+              </a:rPr>
+              <a:t>Yeni </a:t>
+            </a:r>
+            <a:r>
+              <a:rPr lang="az-Latn-AZ" altLang="en-US" sz="1300" b="1">
+                <a:latin typeface="Arial" panose="020B0604020202020204" pitchFamily="34" charset="0"/>
+              </a:rPr>
+              <a:t>Fashion</a:t>
+            </a:r>
+            <a:r>
+              <a:rPr lang="az-Latn-AZ" altLang="en-US" sz="1300">
+                <a:latin typeface="Arial" panose="020B0604020202020204" pitchFamily="34" charset="0"/>
+              </a:rPr>
+              <a:t> adında </a:t>
+            </a:r>
+            <a:r>
+              <a:rPr lang="az-Latn-AZ" altLang="en-US" sz="1300" b="1">
+                <a:solidFill>
+                  <a:srgbClr val="FF0000"/>
+                </a:solidFill>
+                <a:latin typeface="Arial" panose="020B0604020202020204" pitchFamily="34" charset="0"/>
+              </a:rPr>
+              <a:t>Category</a:t>
+            </a:r>
+            <a:r>
+              <a:rPr lang="az-Latn-AZ" altLang="en-US" sz="1300">
+                <a:latin typeface="Arial" panose="020B0604020202020204" pitchFamily="34" charset="0"/>
+              </a:rPr>
+              <a:t> əlavə edirik.</a:t>
+            </a:r>
+            <a:endParaRPr kumimoji="0" lang="en-US" altLang="en-US" sz="1300" b="0" i="0" u="none" strike="noStrike" cap="none" normalizeH="0" baseline="0">
+              <a:ln>
+                <a:noFill/>
+              </a:ln>
+              <a:solidFill>
+                <a:schemeClr val="tx1"/>
+              </a:solidFill>
+              <a:effectLst/>
+              <a:latin typeface="Arial" panose="020B0604020202020204" pitchFamily="34" charset="0"/>
+            </a:endParaRPr>
+          </a:p>
+        </p:txBody>
+      </p:sp>
+      <p:pic>
+        <p:nvPicPr>
+          <p:cNvPr id="4" name="Picture 3">
+            <a:extLst>
+              <a:ext uri="{FF2B5EF4-FFF2-40B4-BE49-F238E27FC236}">
+                <a16:creationId xmlns:a16="http://schemas.microsoft.com/office/drawing/2014/main" id="{D8F3149E-94A8-2AA4-7FE1-32C58874AB14}"/>
+              </a:ext>
+            </a:extLst>
+          </p:cNvPr>
+          <p:cNvPicPr>
+            <a:picLocks noChangeAspect="1"/>
+          </p:cNvPicPr>
+          <p:nvPr/>
+        </p:nvPicPr>
+        <p:blipFill>
+          <a:blip r:embed="rId2"/>
+          <a:stretch>
+            <a:fillRect/>
+          </a:stretch>
+        </p:blipFill>
+        <p:spPr>
+          <a:xfrm>
+            <a:off x="0" y="1582801"/>
+            <a:ext cx="12192000" cy="3692398"/>
+          </a:xfrm>
+          <a:prstGeom prst="rect">
+            <a:avLst/>
+          </a:prstGeom>
+          <a:ln w="38100" cap="sq">
+            <a:solidFill>
+              <a:srgbClr val="000000"/>
+            </a:solidFill>
+            <a:prstDash val="solid"/>
+            <a:miter lim="800000"/>
+          </a:ln>
+          <a:effectLst>
+            <a:outerShdw blurRad="50800" dist="38100" dir="2700000" algn="tl" rotWithShape="0">
+              <a:srgbClr val="000000">
+                <a:alpha val="43000"/>
+              </a:srgbClr>
+            </a:outerShdw>
+          </a:effectLst>
+        </p:spPr>
+      </p:pic>
+    </p:spTree>
+    <p:extLst>
+      <p:ext uri="{BB962C8B-B14F-4D97-AF65-F5344CB8AC3E}">
+        <p14:creationId xmlns:p14="http://schemas.microsoft.com/office/powerpoint/2010/main" val="4222317287"/>
+      </p:ext>
+    </p:extLst>
+  </p:cSld>
+  <p:clrMapOvr>
+    <a:masterClrMapping/>
+  </p:clrMapOvr>
+</p:sld>
+</file>
+
+<file path=ppt/slides/slide5.xml><?xml version="1.0" encoding="utf-8"?>
+<p:sld xmlns:a="http://schemas.openxmlformats.org/drawingml/2006/main" xmlns:r="http://schemas.openxmlformats.org/officeDocument/2006/relationships" xmlns:p="http://schemas.openxmlformats.org/presentationml/2006/main">
+  <p:cSld>
+    <p:spTree>
+      <p:nvGrpSpPr>
+        <p:cNvPr id="1" name="">
+          <a:extLst>
+            <a:ext uri="{FF2B5EF4-FFF2-40B4-BE49-F238E27FC236}">
+              <a16:creationId xmlns:a16="http://schemas.microsoft.com/office/drawing/2014/main" id="{61719F5B-F403-653A-966B-5CF573E71837}"/>
+            </a:ext>
+          </a:extLst>
+        </p:cNvPr>
+        <p:cNvGrpSpPr/>
+        <p:nvPr/>
+      </p:nvGrpSpPr>
+      <p:grpSpPr>
+        <a:xfrm>
+          <a:off x="0" y="0"/>
+          <a:ext cx="0" cy="0"/>
+          <a:chOff x="0" y="0"/>
+          <a:chExt cx="0" cy="0"/>
+        </a:xfrm>
+      </p:grpSpPr>
+      <p:sp>
+        <p:nvSpPr>
+          <p:cNvPr id="3" name="TextBox 2">
+            <a:extLst>
+              <a:ext uri="{FF2B5EF4-FFF2-40B4-BE49-F238E27FC236}">
+                <a16:creationId xmlns:a16="http://schemas.microsoft.com/office/drawing/2014/main" id="{7B163ED5-A8B8-1934-511E-730A02D7FCB0}"/>
+              </a:ext>
+            </a:extLst>
+          </p:cNvPr>
+          <p:cNvSpPr txBox="1"/>
+          <p:nvPr/>
+        </p:nvSpPr>
+        <p:spPr>
+          <a:xfrm>
+            <a:off x="217714" y="255046"/>
+            <a:ext cx="11756571" cy="355354"/>
+          </a:xfrm>
+          <a:prstGeom prst="rect">
+            <a:avLst/>
+          </a:prstGeom>
+          <a:noFill/>
+        </p:spPr>
+        <p:txBody>
+          <a:bodyPr wrap="square">
+            <a:spAutoFit/>
+          </a:bodyPr>
+          <a:lstStyle/>
+          <a:p>
+            <a:pPr>
+              <a:lnSpc>
+                <a:spcPct val="150000"/>
+              </a:lnSpc>
+              <a:buNone/>
+            </a:pPr>
+            <a:r>
+              <a:rPr lang="en-US" altLang="en-US" sz="1300" b="1">
+                <a:latin typeface="Arial" panose="020B0604020202020204" pitchFamily="34" charset="0"/>
+              </a:rPr>
+              <a:t>Fashion</a:t>
+            </a:r>
+            <a:r>
+              <a:rPr lang="az-Latn-AZ" altLang="en-US" sz="1300">
+                <a:latin typeface="Arial" panose="020B0604020202020204" pitchFamily="34" charset="0"/>
+              </a:rPr>
+              <a:t> adındakı </a:t>
+            </a:r>
+            <a:r>
+              <a:rPr lang="az-Latn-AZ" altLang="en-US" sz="1300" b="1">
+                <a:solidFill>
+                  <a:srgbClr val="FF0000"/>
+                </a:solidFill>
+                <a:latin typeface="Arial" panose="020B0604020202020204" pitchFamily="34" charset="0"/>
+              </a:rPr>
+              <a:t>Category</a:t>
+            </a:r>
+            <a:r>
+              <a:rPr lang="az-Latn-AZ" altLang="en-US" sz="1300">
+                <a:latin typeface="Arial" panose="020B0604020202020204" pitchFamily="34" charset="0"/>
+              </a:rPr>
+              <a:t> üçün </a:t>
+            </a:r>
+            <a:r>
+              <a:rPr lang="az-Latn-AZ" altLang="en-US" sz="1300" b="1">
+                <a:latin typeface="Arial" panose="020B0604020202020204" pitchFamily="34" charset="0"/>
+              </a:rPr>
+              <a:t>Men</a:t>
+            </a:r>
+            <a:r>
+              <a:rPr lang="az-Latn-AZ" altLang="en-US" sz="1300">
+                <a:latin typeface="Arial" panose="020B0604020202020204" pitchFamily="34" charset="0"/>
+              </a:rPr>
+              <a:t> adında </a:t>
+            </a:r>
+            <a:r>
+              <a:rPr lang="az-Latn-AZ" altLang="en-US" sz="1300" b="1">
+                <a:solidFill>
+                  <a:srgbClr val="FF0000"/>
+                </a:solidFill>
+                <a:latin typeface="Arial" panose="020B0604020202020204" pitchFamily="34" charset="0"/>
+              </a:rPr>
+              <a:t>Sub Category </a:t>
+            </a:r>
+            <a:r>
+              <a:rPr lang="az-Latn-AZ" altLang="en-US" sz="1300">
+                <a:latin typeface="Arial" panose="020B0604020202020204" pitchFamily="34" charset="0"/>
+              </a:rPr>
+              <a:t>əlavə edirik.</a:t>
+            </a:r>
+            <a:endParaRPr lang="en-US" altLang="en-US" sz="1300">
+              <a:latin typeface="Arial" panose="020B0604020202020204" pitchFamily="34" charset="0"/>
+            </a:endParaRPr>
+          </a:p>
+        </p:txBody>
+      </p:sp>
+      <p:pic>
+        <p:nvPicPr>
+          <p:cNvPr id="4" name="Picture 3">
+            <a:extLst>
+              <a:ext uri="{FF2B5EF4-FFF2-40B4-BE49-F238E27FC236}">
+                <a16:creationId xmlns:a16="http://schemas.microsoft.com/office/drawing/2014/main" id="{CE01E2F9-8387-A962-5D65-2BD82DA457F4}"/>
+              </a:ext>
+            </a:extLst>
+          </p:cNvPr>
+          <p:cNvPicPr>
+            <a:picLocks noChangeAspect="1"/>
+          </p:cNvPicPr>
+          <p:nvPr/>
+        </p:nvPicPr>
+        <p:blipFill>
+          <a:blip r:embed="rId2"/>
+          <a:stretch>
+            <a:fillRect/>
+          </a:stretch>
+        </p:blipFill>
+        <p:spPr>
+          <a:xfrm>
+            <a:off x="0" y="1595114"/>
+            <a:ext cx="12192000" cy="3667771"/>
+          </a:xfrm>
+          <a:prstGeom prst="rect">
+            <a:avLst/>
+          </a:prstGeom>
+          <a:ln w="38100" cap="sq">
+            <a:solidFill>
+              <a:srgbClr val="000000"/>
+            </a:solidFill>
+            <a:prstDash val="solid"/>
+            <a:miter lim="800000"/>
+          </a:ln>
+          <a:effectLst>
+            <a:outerShdw blurRad="50800" dist="38100" dir="2700000" algn="tl" rotWithShape="0">
+              <a:srgbClr val="000000">
+                <a:alpha val="43000"/>
+              </a:srgbClr>
+            </a:outerShdw>
+          </a:effectLst>
+        </p:spPr>
+      </p:pic>
+    </p:spTree>
+    <p:extLst>
+      <p:ext uri="{BB962C8B-B14F-4D97-AF65-F5344CB8AC3E}">
+        <p14:creationId xmlns:p14="http://schemas.microsoft.com/office/powerpoint/2010/main" val="177763949"/>
+      </p:ext>
+    </p:extLst>
+  </p:cSld>
+  <p:clrMapOvr>
+    <a:masterClrMapping/>
+  </p:clrMapOvr>
+</p:sld>
+</file>
+
+<file path=ppt/slides/slide6.xml><?xml version="1.0" encoding="utf-8"?>
+<p:sld xmlns:a="http://schemas.openxmlformats.org/drawingml/2006/main" xmlns:r="http://schemas.openxmlformats.org/officeDocument/2006/relationships" xmlns:p="http://schemas.openxmlformats.org/presentationml/2006/main">
+  <p:cSld>
+    <p:spTree>
+      <p:nvGrpSpPr>
+        <p:cNvPr id="1" name="">
+          <a:extLst>
+            <a:ext uri="{FF2B5EF4-FFF2-40B4-BE49-F238E27FC236}">
+              <a16:creationId xmlns:a16="http://schemas.microsoft.com/office/drawing/2014/main" id="{0C8E9D8D-56E0-A94D-1C65-A1F671458981}"/>
+            </a:ext>
+          </a:extLst>
+        </p:cNvPr>
+        <p:cNvGrpSpPr/>
+        <p:nvPr/>
+      </p:nvGrpSpPr>
+      <p:grpSpPr>
+        <a:xfrm>
+          <a:off x="0" y="0"/>
+          <a:ext cx="0" cy="0"/>
+          <a:chOff x="0" y="0"/>
+          <a:chExt cx="0" cy="0"/>
+        </a:xfrm>
+      </p:grpSpPr>
+      <p:sp>
+        <p:nvSpPr>
+          <p:cNvPr id="3" name="TextBox 2">
+            <a:extLst>
+              <a:ext uri="{FF2B5EF4-FFF2-40B4-BE49-F238E27FC236}">
+                <a16:creationId xmlns:a16="http://schemas.microsoft.com/office/drawing/2014/main" id="{BC158E50-0D0A-79CB-0E5B-CDA1F18B5B33}"/>
+              </a:ext>
+            </a:extLst>
+          </p:cNvPr>
+          <p:cNvSpPr txBox="1"/>
+          <p:nvPr/>
+        </p:nvSpPr>
+        <p:spPr>
+          <a:xfrm>
+            <a:off x="217714" y="255046"/>
+            <a:ext cx="11756571" cy="355354"/>
+          </a:xfrm>
+          <a:prstGeom prst="rect">
+            <a:avLst/>
+          </a:prstGeom>
+          <a:noFill/>
+        </p:spPr>
+        <p:txBody>
+          <a:bodyPr wrap="square">
+            <a:spAutoFit/>
+          </a:bodyPr>
+          <a:lstStyle/>
+          <a:p>
+            <a:pPr>
+              <a:lnSpc>
+                <a:spcPct val="150000"/>
+              </a:lnSpc>
+              <a:buNone/>
+            </a:pPr>
+            <a:r>
+              <a:rPr lang="az-Latn-AZ" altLang="en-US" sz="1300" b="1">
+                <a:latin typeface="Arial" panose="020B0604020202020204" pitchFamily="34" charset="0"/>
+              </a:rPr>
+              <a:t>Men</a:t>
+            </a:r>
+            <a:r>
+              <a:rPr lang="az-Latn-AZ" altLang="en-US" sz="1300">
+                <a:latin typeface="Arial" panose="020B0604020202020204" pitchFamily="34" charset="0"/>
+              </a:rPr>
+              <a:t> adında </a:t>
+            </a:r>
+            <a:r>
+              <a:rPr lang="az-Latn-AZ" altLang="en-US" sz="1300" b="1">
+                <a:solidFill>
+                  <a:srgbClr val="FF0000"/>
+                </a:solidFill>
+                <a:latin typeface="Arial" panose="020B0604020202020204" pitchFamily="34" charset="0"/>
+              </a:rPr>
+              <a:t>Sub</a:t>
+            </a:r>
+            <a:r>
+              <a:rPr lang="az-Latn-AZ" altLang="en-US" sz="1300">
+                <a:solidFill>
+                  <a:srgbClr val="FF0000"/>
+                </a:solidFill>
+                <a:latin typeface="Arial" panose="020B0604020202020204" pitchFamily="34" charset="0"/>
+              </a:rPr>
+              <a:t> </a:t>
+            </a:r>
+            <a:r>
+              <a:rPr lang="az-Latn-AZ" altLang="en-US" sz="1300" b="1">
+                <a:solidFill>
+                  <a:srgbClr val="FF0000"/>
+                </a:solidFill>
+                <a:latin typeface="Arial" panose="020B0604020202020204" pitchFamily="34" charset="0"/>
+              </a:rPr>
+              <a:t>Category</a:t>
+            </a:r>
+            <a:r>
+              <a:rPr lang="az-Latn-AZ" altLang="en-US" sz="1300">
+                <a:solidFill>
+                  <a:srgbClr val="FF0000"/>
+                </a:solidFill>
+                <a:latin typeface="Arial" panose="020B0604020202020204" pitchFamily="34" charset="0"/>
+              </a:rPr>
+              <a:t> </a:t>
+            </a:r>
+            <a:r>
+              <a:rPr lang="az-Latn-AZ" altLang="en-US" sz="1300">
+                <a:latin typeface="Arial" panose="020B0604020202020204" pitchFamily="34" charset="0"/>
+              </a:rPr>
+              <a:t>üçün </a:t>
+            </a:r>
+            <a:r>
+              <a:rPr lang="az-Latn-AZ" altLang="en-US" sz="1300" b="1">
+                <a:latin typeface="Arial" panose="020B0604020202020204" pitchFamily="34" charset="0"/>
+              </a:rPr>
+              <a:t>Shirt </a:t>
+            </a:r>
+            <a:r>
+              <a:rPr lang="az-Latn-AZ" altLang="en-US" sz="1300">
+                <a:latin typeface="Arial" panose="020B0604020202020204" pitchFamily="34" charset="0"/>
+              </a:rPr>
+              <a:t>adında </a:t>
+            </a:r>
+            <a:r>
+              <a:rPr lang="az-Latn-AZ" altLang="en-US" sz="1300" b="1">
+                <a:solidFill>
+                  <a:srgbClr val="FF0000"/>
+                </a:solidFill>
+                <a:latin typeface="Arial" panose="020B0604020202020204" pitchFamily="34" charset="0"/>
+              </a:rPr>
+              <a:t>Child</a:t>
+            </a:r>
+            <a:r>
+              <a:rPr lang="az-Latn-AZ" altLang="en-US" sz="1300">
+                <a:solidFill>
+                  <a:srgbClr val="FF0000"/>
+                </a:solidFill>
+                <a:latin typeface="Arial" panose="020B0604020202020204" pitchFamily="34" charset="0"/>
+              </a:rPr>
+              <a:t> </a:t>
+            </a:r>
+            <a:r>
+              <a:rPr lang="az-Latn-AZ" altLang="en-US" sz="1300" b="1">
+                <a:solidFill>
+                  <a:srgbClr val="FF0000"/>
+                </a:solidFill>
+                <a:latin typeface="Arial" panose="020B0604020202020204" pitchFamily="34" charset="0"/>
+              </a:rPr>
+              <a:t>Category</a:t>
+            </a:r>
+            <a:r>
+              <a:rPr lang="az-Latn-AZ" altLang="en-US" sz="1300">
+                <a:solidFill>
+                  <a:srgbClr val="FF0000"/>
+                </a:solidFill>
+                <a:latin typeface="Arial" panose="020B0604020202020204" pitchFamily="34" charset="0"/>
+              </a:rPr>
+              <a:t> </a:t>
+            </a:r>
+            <a:r>
+              <a:rPr lang="az-Latn-AZ" altLang="en-US" sz="1300">
+                <a:latin typeface="Arial" panose="020B0604020202020204" pitchFamily="34" charset="0"/>
+              </a:rPr>
+              <a:t>əlavə edirik.</a:t>
+            </a:r>
+            <a:endParaRPr lang="en-US" altLang="en-US" sz="1300">
+              <a:latin typeface="Arial" panose="020B0604020202020204" pitchFamily="34" charset="0"/>
+            </a:endParaRPr>
+          </a:p>
+        </p:txBody>
+      </p:sp>
+      <p:pic>
+        <p:nvPicPr>
+          <p:cNvPr id="4" name="Picture 3">
+            <a:extLst>
+              <a:ext uri="{FF2B5EF4-FFF2-40B4-BE49-F238E27FC236}">
+                <a16:creationId xmlns:a16="http://schemas.microsoft.com/office/drawing/2014/main" id="{3559E980-5964-EFAD-143E-213F0B24D459}"/>
+              </a:ext>
+            </a:extLst>
+          </p:cNvPr>
+          <p:cNvPicPr>
+            <a:picLocks noChangeAspect="1"/>
+          </p:cNvPicPr>
+          <p:nvPr/>
+        </p:nvPicPr>
+        <p:blipFill>
+          <a:blip r:embed="rId2"/>
+          <a:stretch>
+            <a:fillRect/>
+          </a:stretch>
+        </p:blipFill>
+        <p:spPr>
+          <a:xfrm>
+            <a:off x="0" y="1602424"/>
+            <a:ext cx="12192000" cy="3653152"/>
+          </a:xfrm>
+          <a:prstGeom prst="rect">
+            <a:avLst/>
+          </a:prstGeom>
+          <a:ln w="38100" cap="sq">
+            <a:solidFill>
+              <a:srgbClr val="000000"/>
+            </a:solidFill>
+            <a:prstDash val="solid"/>
+            <a:miter lim="800000"/>
+          </a:ln>
+          <a:effectLst>
+            <a:outerShdw blurRad="50800" dist="38100" dir="2700000" algn="tl" rotWithShape="0">
+              <a:srgbClr val="000000">
+                <a:alpha val="43000"/>
+              </a:srgbClr>
+            </a:outerShdw>
+          </a:effectLst>
+        </p:spPr>
+      </p:pic>
+    </p:spTree>
+    <p:extLst>
+      <p:ext uri="{BB962C8B-B14F-4D97-AF65-F5344CB8AC3E}">
+        <p14:creationId xmlns:p14="http://schemas.microsoft.com/office/powerpoint/2010/main" val="2038483837"/>
+      </p:ext>
+    </p:extLst>
+  </p:cSld>
+  <p:clrMapOvr>
+    <a:masterClrMapping/>
+  </p:clrMapOvr>
+</p:sld>
+</file>
+
+<file path=ppt/slides/slide7.xml><?xml version="1.0" encoding="utf-8"?>
+<p:sld xmlns:a="http://schemas.openxmlformats.org/drawingml/2006/main" xmlns:r="http://schemas.openxmlformats.org/officeDocument/2006/relationships" xmlns:p="http://schemas.openxmlformats.org/presentationml/2006/main">
+  <p:cSld>
+    <p:spTree>
+      <p:nvGrpSpPr>
+        <p:cNvPr id="1" name="">
+          <a:extLst>
+            <a:ext uri="{FF2B5EF4-FFF2-40B4-BE49-F238E27FC236}">
+              <a16:creationId xmlns:a16="http://schemas.microsoft.com/office/drawing/2014/main" id="{DAA709B5-17E1-1D2B-DC70-6DBBBD46A65B}"/>
+            </a:ext>
+          </a:extLst>
+        </p:cNvPr>
+        <p:cNvGrpSpPr/>
+        <p:nvPr/>
+      </p:nvGrpSpPr>
+      <p:grpSpPr>
+        <a:xfrm>
+          <a:off x="0" y="0"/>
+          <a:ext cx="0" cy="0"/>
+          <a:chOff x="0" y="0"/>
+          <a:chExt cx="0" cy="0"/>
+        </a:xfrm>
+      </p:grpSpPr>
+      <p:sp>
+        <p:nvSpPr>
+          <p:cNvPr id="3" name="TextBox 2">
+            <a:extLst>
+              <a:ext uri="{FF2B5EF4-FFF2-40B4-BE49-F238E27FC236}">
+                <a16:creationId xmlns:a16="http://schemas.microsoft.com/office/drawing/2014/main" id="{5DE024B0-E556-97F2-DF7B-DA9E80A5F830}"/>
+              </a:ext>
+            </a:extLst>
+          </p:cNvPr>
+          <p:cNvSpPr txBox="1"/>
+          <p:nvPr/>
+        </p:nvSpPr>
+        <p:spPr>
+          <a:xfrm>
+            <a:off x="217714" y="255046"/>
+            <a:ext cx="11756571" cy="1255600"/>
+          </a:xfrm>
+          <a:prstGeom prst="rect">
+            <a:avLst/>
+          </a:prstGeom>
+          <a:noFill/>
+        </p:spPr>
+        <p:txBody>
+          <a:bodyPr wrap="square">
+            <a:spAutoFit/>
+          </a:bodyPr>
+          <a:lstStyle/>
+          <a:p>
+            <a:pPr>
+              <a:lnSpc>
+                <a:spcPct val="150000"/>
+              </a:lnSpc>
+              <a:buNone/>
+            </a:pPr>
+            <a:r>
+              <a:rPr lang="az-Latn-AZ" altLang="en-US" sz="1300">
+                <a:latin typeface="Arial" panose="020B0604020202020204" pitchFamily="34" charset="0"/>
+              </a:rPr>
+              <a:t>İndi elə edəcəyik ki, əgər Category -nin, SubCategory -si, yaxud SubCategory -nin, ChildCategory -si varsa onda onu silmək mümkün olmasın.</a:t>
+            </a:r>
+          </a:p>
+          <a:p>
+            <a:pPr>
+              <a:lnSpc>
+                <a:spcPct val="150000"/>
+              </a:lnSpc>
+              <a:buNone/>
+            </a:pPr>
+            <a:endParaRPr kumimoji="0" lang="az-Latn-AZ" altLang="en-US" sz="1300" b="0" i="0" u="none" strike="noStrike" cap="none" normalizeH="0" baseline="0">
+              <a:ln>
+                <a:noFill/>
+              </a:ln>
+              <a:solidFill>
+                <a:schemeClr val="tx1"/>
+              </a:solidFill>
+              <a:effectLst/>
+              <a:latin typeface="Arial" panose="020B0604020202020204" pitchFamily="34" charset="0"/>
+            </a:endParaRPr>
+          </a:p>
+          <a:p>
+            <a:pPr marL="285750" indent="-285750">
+              <a:lnSpc>
+                <a:spcPct val="150000"/>
+              </a:lnSpc>
+              <a:buFont typeface="Arial" panose="020B0604020202020204" pitchFamily="34" charset="0"/>
+              <a:buChar char="•"/>
+            </a:pPr>
+            <a:r>
+              <a:rPr lang="en-US" altLang="en-US" sz="1300">
+                <a:latin typeface="Arial" panose="020B0604020202020204" pitchFamily="34" charset="0"/>
+              </a:rPr>
+              <a:t>app\Http\Controllers\Backend\CategoryController.php</a:t>
+            </a:r>
+            <a:endParaRPr lang="az-Latn-AZ" altLang="en-US" sz="1300">
+              <a:latin typeface="Arial" panose="020B0604020202020204" pitchFamily="34" charset="0"/>
+            </a:endParaRPr>
+          </a:p>
+          <a:p>
+            <a:pPr marL="285750" indent="-285750">
+              <a:lnSpc>
+                <a:spcPct val="150000"/>
+              </a:lnSpc>
+              <a:buFont typeface="Arial" panose="020B0604020202020204" pitchFamily="34" charset="0"/>
+              <a:buChar char="•"/>
+            </a:pPr>
+            <a:r>
+              <a:rPr lang="en-US" altLang="en-US" sz="1300">
+                <a:latin typeface="Arial" panose="020B0604020202020204" pitchFamily="34" charset="0"/>
+              </a:rPr>
+              <a:t>app\Http\Controllers\Backend\SubCategoryController.php</a:t>
+            </a:r>
+            <a:endParaRPr kumimoji="0" lang="en-US" altLang="en-US" sz="1300" b="0" i="0" u="none" strike="noStrike" cap="none" normalizeH="0" baseline="0">
+              <a:ln>
+                <a:noFill/>
+              </a:ln>
+              <a:solidFill>
+                <a:schemeClr val="tx1"/>
+              </a:solidFill>
+              <a:effectLst/>
+              <a:latin typeface="Arial" panose="020B0604020202020204" pitchFamily="34" charset="0"/>
+            </a:endParaRPr>
+          </a:p>
+        </p:txBody>
+      </p:sp>
+      <p:pic>
+        <p:nvPicPr>
+          <p:cNvPr id="4" name="Picture 3">
+            <a:extLst>
+              <a:ext uri="{FF2B5EF4-FFF2-40B4-BE49-F238E27FC236}">
+                <a16:creationId xmlns:a16="http://schemas.microsoft.com/office/drawing/2014/main" id="{BC572CAA-7B72-BDF7-C801-B829E318E4C5}"/>
+              </a:ext>
+            </a:extLst>
+          </p:cNvPr>
+          <p:cNvPicPr>
+            <a:picLocks noChangeAspect="1"/>
+          </p:cNvPicPr>
+          <p:nvPr/>
+        </p:nvPicPr>
+        <p:blipFill>
+          <a:blip r:embed="rId2"/>
+          <a:stretch>
+            <a:fillRect/>
+          </a:stretch>
+        </p:blipFill>
+        <p:spPr>
+          <a:xfrm>
+            <a:off x="3906982" y="1695994"/>
+            <a:ext cx="8285018" cy="5162005"/>
+          </a:xfrm>
+          <a:prstGeom prst="rect">
+            <a:avLst/>
+          </a:prstGeom>
+        </p:spPr>
+      </p:pic>
+    </p:spTree>
+    <p:extLst>
+      <p:ext uri="{BB962C8B-B14F-4D97-AF65-F5344CB8AC3E}">
+        <p14:creationId xmlns:p14="http://schemas.microsoft.com/office/powerpoint/2010/main" val="880082743"/>
+      </p:ext>
+    </p:extLst>
+  </p:cSld>
+  <p:clrMapOvr>
+    <a:masterClrMapping/>
+  </p:clrMapOvr>
+</p:sld>
+</file>
+
+<file path=ppt/slides/slide8.xml><?xml version="1.0" encoding="utf-8"?>
+<p:sld xmlns:a="http://schemas.openxmlformats.org/drawingml/2006/main" xmlns:r="http://schemas.openxmlformats.org/officeDocument/2006/relationships" xmlns:p="http://schemas.openxmlformats.org/presentationml/2006/main">
+  <p:cSld>
+    <p:spTree>
+      <p:nvGrpSpPr>
+        <p:cNvPr id="1" name="">
+          <a:extLst>
+            <a:ext uri="{FF2B5EF4-FFF2-40B4-BE49-F238E27FC236}">
+              <a16:creationId xmlns:a16="http://schemas.microsoft.com/office/drawing/2014/main" id="{780637DA-05B8-BE0F-5776-FA23D516F031}"/>
+            </a:ext>
+          </a:extLst>
+        </p:cNvPr>
+        <p:cNvGrpSpPr/>
+        <p:nvPr/>
+      </p:nvGrpSpPr>
+      <p:grpSpPr>
+        <a:xfrm>
+          <a:off x="0" y="0"/>
+          <a:ext cx="0" cy="0"/>
+          <a:chOff x="0" y="0"/>
+          <a:chExt cx="0" cy="0"/>
+        </a:xfrm>
+      </p:grpSpPr>
+      <p:sp>
+        <p:nvSpPr>
+          <p:cNvPr id="3" name="TextBox 2">
+            <a:extLst>
+              <a:ext uri="{FF2B5EF4-FFF2-40B4-BE49-F238E27FC236}">
+                <a16:creationId xmlns:a16="http://schemas.microsoft.com/office/drawing/2014/main" id="{7DFA0F4C-47F9-9C98-409B-B350806A33AE}"/>
+              </a:ext>
+            </a:extLst>
+          </p:cNvPr>
+          <p:cNvSpPr txBox="1"/>
+          <p:nvPr/>
+        </p:nvSpPr>
+        <p:spPr>
+          <a:xfrm>
+            <a:off x="217715" y="255046"/>
+            <a:ext cx="7152904" cy="955518"/>
+          </a:xfrm>
+          <a:prstGeom prst="rect">
+            <a:avLst/>
+          </a:prstGeom>
+          <a:noFill/>
+        </p:spPr>
+        <p:txBody>
+          <a:bodyPr wrap="square">
+            <a:spAutoFit/>
+          </a:bodyPr>
+          <a:lstStyle/>
+          <a:p>
+            <a:pPr>
+              <a:lnSpc>
+                <a:spcPct val="150000"/>
+              </a:lnSpc>
+              <a:buNone/>
+            </a:pPr>
+            <a:r>
+              <a:rPr lang="az-Latn-AZ" altLang="en-US" sz="1300" b="1">
+                <a:latin typeface="Arial" panose="020B0604020202020204" pitchFamily="34" charset="0"/>
+              </a:rPr>
+              <a:t>DELETE</a:t>
+            </a:r>
+            <a:r>
+              <a:rPr lang="az-Latn-AZ" altLang="en-US" sz="1300">
+                <a:latin typeface="Arial" panose="020B0604020202020204" pitchFamily="34" charset="0"/>
+              </a:rPr>
+              <a:t> düyməsini kliklədikdə, `</a:t>
+            </a:r>
+            <a:r>
+              <a:rPr lang="en-US" altLang="en-US" sz="1300">
+                <a:latin typeface="Arial" panose="020B0604020202020204" pitchFamily="34" charset="0"/>
+              </a:rPr>
+              <a:t> </a:t>
+            </a:r>
+            <a:r>
+              <a:rPr lang="en-US" altLang="en-US" sz="1300" b="1">
+                <a:latin typeface="Arial" panose="020B0604020202020204" pitchFamily="34" charset="0"/>
+              </a:rPr>
+              <a:t>resources\views\admin\layouts\master.blade.php </a:t>
+            </a:r>
+            <a:r>
+              <a:rPr lang="az-Latn-AZ" altLang="en-US" sz="1300">
+                <a:latin typeface="Arial" panose="020B0604020202020204" pitchFamily="34" charset="0"/>
+              </a:rPr>
+              <a:t>` faylındakı </a:t>
+            </a:r>
+            <a:r>
+              <a:rPr kumimoji="0" lang="az-Latn-AZ" altLang="en-US" sz="1300" b="1" i="0" u="none" strike="noStrike" cap="none" normalizeH="0" baseline="0">
+                <a:ln>
+                  <a:noFill/>
+                </a:ln>
+                <a:solidFill>
+                  <a:schemeClr val="tx1"/>
+                </a:solidFill>
+                <a:effectLst/>
+                <a:latin typeface="Arial" panose="020B0604020202020204" pitchFamily="34" charset="0"/>
+              </a:rPr>
+              <a:t>Jquery</a:t>
+            </a:r>
+            <a:r>
+              <a:rPr kumimoji="0" lang="az-Latn-AZ" altLang="en-US" sz="1300" b="0" i="0" u="none" strike="noStrike" cap="none" normalizeH="0" baseline="0">
+                <a:ln>
+                  <a:noFill/>
+                </a:ln>
+                <a:solidFill>
+                  <a:schemeClr val="tx1"/>
+                </a:solidFill>
+                <a:effectLst/>
+                <a:latin typeface="Arial" panose="020B0604020202020204" pitchFamily="34" charset="0"/>
+              </a:rPr>
+              <a:t> </a:t>
+            </a:r>
+            <a:r>
+              <a:rPr lang="az-Latn-AZ" altLang="en-US" sz="1300">
+                <a:latin typeface="Arial" panose="020B0604020202020204" pitchFamily="34" charset="0"/>
+              </a:rPr>
+              <a:t>ilə yazdığımız kod vasitəsi ilə, </a:t>
+            </a:r>
+            <a:r>
+              <a:rPr lang="az-Latn-AZ" altLang="en-US" sz="1300" b="1">
+                <a:latin typeface="Arial" panose="020B0604020202020204" pitchFamily="34" charset="0"/>
+              </a:rPr>
+              <a:t>response</a:t>
+            </a:r>
+            <a:r>
+              <a:rPr lang="az-Latn-AZ" altLang="en-US" sz="1300">
+                <a:latin typeface="Arial" panose="020B0604020202020204" pitchFamily="34" charset="0"/>
+              </a:rPr>
+              <a:t> -u tuturuq və buna görə mesaj əks etdiririk.</a:t>
+            </a:r>
+            <a:endParaRPr kumimoji="0" lang="en-US" altLang="en-US" sz="1300" b="0" i="0" u="none" strike="noStrike" cap="none" normalizeH="0" baseline="0">
+              <a:ln>
+                <a:noFill/>
+              </a:ln>
+              <a:solidFill>
+                <a:schemeClr val="tx1"/>
+              </a:solidFill>
+              <a:effectLst/>
+              <a:latin typeface="Arial" panose="020B0604020202020204" pitchFamily="34" charset="0"/>
+            </a:endParaRPr>
+          </a:p>
+        </p:txBody>
+      </p:sp>
+      <p:pic>
+        <p:nvPicPr>
+          <p:cNvPr id="4" name="Picture 3">
+            <a:extLst>
+              <a:ext uri="{FF2B5EF4-FFF2-40B4-BE49-F238E27FC236}">
+                <a16:creationId xmlns:a16="http://schemas.microsoft.com/office/drawing/2014/main" id="{486ADD6B-202D-2CD8-9D4C-E5FF2981BB49}"/>
+              </a:ext>
+            </a:extLst>
+          </p:cNvPr>
+          <p:cNvPicPr>
+            <a:picLocks noChangeAspect="1"/>
+          </p:cNvPicPr>
+          <p:nvPr/>
+        </p:nvPicPr>
+        <p:blipFill>
+          <a:blip r:embed="rId2"/>
+          <a:stretch>
+            <a:fillRect/>
+          </a:stretch>
+        </p:blipFill>
+        <p:spPr>
+          <a:xfrm>
+            <a:off x="7455020" y="0"/>
+            <a:ext cx="4746216" cy="6858000"/>
+          </a:xfrm>
+          <a:prstGeom prst="rect">
+            <a:avLst/>
+          </a:prstGeom>
+        </p:spPr>
+      </p:pic>
+    </p:spTree>
+    <p:extLst>
+      <p:ext uri="{BB962C8B-B14F-4D97-AF65-F5344CB8AC3E}">
+        <p14:creationId xmlns:p14="http://schemas.microsoft.com/office/powerpoint/2010/main" val="3883044182"/>
+      </p:ext>
+    </p:extLst>
+  </p:cSld>
+  <p:clrMapOvr>
+    <a:masterClrMapping/>
+  </p:clrMapOvr>
+</p:sld>
+</file>
+
+<file path=ppt/slides/slide9.xml><?xml version="1.0" encoding="utf-8"?>
+<p:sld xmlns:a="http://schemas.openxmlformats.org/drawingml/2006/main" xmlns:r="http://schemas.openxmlformats.org/officeDocument/2006/relationships" xmlns:p="http://schemas.openxmlformats.org/presentationml/2006/main">
+  <p:cSld>
+    <p:spTree>
+      <p:nvGrpSpPr>
+        <p:cNvPr id="1" name="">
+          <a:extLst>
+            <a:ext uri="{FF2B5EF4-FFF2-40B4-BE49-F238E27FC236}">
+              <a16:creationId xmlns:a16="http://schemas.microsoft.com/office/drawing/2014/main" id="{714BD7CA-7805-48EE-76D6-607EC0EE5E77}"/>
+            </a:ext>
+          </a:extLst>
+        </p:cNvPr>
+        <p:cNvGrpSpPr/>
+        <p:nvPr/>
+      </p:nvGrpSpPr>
+      <p:grpSpPr>
+        <a:xfrm>
+          <a:off x="0" y="0"/>
+          <a:ext cx="0" cy="0"/>
+          <a:chOff x="0" y="0"/>
+          <a:chExt cx="0" cy="0"/>
+        </a:xfrm>
+      </p:grpSpPr>
+      <p:sp>
+        <p:nvSpPr>
+          <p:cNvPr id="3" name="TextBox 2">
+            <a:extLst>
+              <a:ext uri="{FF2B5EF4-FFF2-40B4-BE49-F238E27FC236}">
+                <a16:creationId xmlns:a16="http://schemas.microsoft.com/office/drawing/2014/main" id="{ECC75994-210E-88E5-7FD5-6672B5C50C0A}"/>
+              </a:ext>
+            </a:extLst>
+          </p:cNvPr>
+          <p:cNvSpPr txBox="1"/>
+          <p:nvPr/>
+        </p:nvSpPr>
+        <p:spPr>
+          <a:xfrm>
+            <a:off x="217714" y="255046"/>
+            <a:ext cx="11756571" cy="355354"/>
+          </a:xfrm>
+          <a:prstGeom prst="rect">
+            <a:avLst/>
+          </a:prstGeom>
+          <a:noFill/>
+        </p:spPr>
+        <p:txBody>
+          <a:bodyPr wrap="square">
+            <a:spAutoFit/>
+          </a:bodyPr>
+          <a:lstStyle/>
+          <a:p>
+            <a:pPr>
+              <a:lnSpc>
+                <a:spcPct val="150000"/>
+              </a:lnSpc>
+              <a:buNone/>
+            </a:pPr>
+            <a:r>
               <a:rPr kumimoji="0" lang="en-US" altLang="en-US" sz="1300" b="0" i="0" u="none" strike="noStrike" cap="none" normalizeH="0" baseline="0">
                 <a:ln>
                   <a:noFill/>
@@ -3556,10 +4939,54 @@
           </a:p>
         </p:txBody>
       </p:sp>
+      <p:pic>
+        <p:nvPicPr>
+          <p:cNvPr id="4" name="Picture 3">
+            <a:extLst>
+              <a:ext uri="{FF2B5EF4-FFF2-40B4-BE49-F238E27FC236}">
+                <a16:creationId xmlns:a16="http://schemas.microsoft.com/office/drawing/2014/main" id="{0AC5633A-0978-0510-66E0-84A7D5AC841B}"/>
+              </a:ext>
+            </a:extLst>
+          </p:cNvPr>
+          <p:cNvPicPr>
+            <a:picLocks noChangeAspect="1"/>
+          </p:cNvPicPr>
+          <p:nvPr/>
+        </p:nvPicPr>
+        <p:blipFill>
+          <a:blip r:embed="rId2"/>
+          <a:stretch>
+            <a:fillRect/>
+          </a:stretch>
+        </p:blipFill>
+        <p:spPr>
+          <a:xfrm>
+            <a:off x="0" y="1265698"/>
+            <a:ext cx="12192000" cy="4326603"/>
+          </a:xfrm>
+          <a:prstGeom prst="rect">
+            <a:avLst/>
+          </a:prstGeom>
+          <a:ln w="38100" cap="sq">
+            <a:solidFill>
+              <a:srgbClr val="000000"/>
+            </a:solidFill>
+            <a:prstDash val="solid"/>
+            <a:miter lim="800000"/>
+          </a:ln>
+          <a:effectLst>
+            <a:outerShdw blurRad="50800" dist="38100" dir="2700000" algn="tl" rotWithShape="0">
+              <a:srgbClr val="000000">
+                <a:alpha val="43000"/>
+              </a:srgbClr>
+            </a:outerShdw>
+          </a:effectLst>
+        </p:spPr>
+      </p:pic>
     </p:spTree>
     <p:extLst>
       <p:ext uri="{BB962C8B-B14F-4D97-AF65-F5344CB8AC3E}">
-        <p14:creationId xmlns:p14="http://schemas.microsoft.com/office/powerpoint/2010/main" val="3095838342"/>
+        <p14:creationId xmlns:p14="http://schemas.microsoft.com/office/powerpoint/2010/main" val="3244861761"/>
       </p:ext>
     </p:extLst>
   </p:cSld>

</xml_diff>